<commit_message>
feat: fixed slide 27
</commit_message>
<xml_diff>
--- a/presentation/0716_4_Lattices.pptx
+++ b/presentation/0716_4_Lattices.pptx
@@ -7510,8 +7510,8 @@
           </a:p>
         </p:txBody>
       </p:sp>
-      <mc:AlternateContent xmlns:mc="http://schemas.openxmlformats.org/markup-compatibility/2006">
-        <mc:Choice xmlns:a14="http://schemas.microsoft.com/office/drawing/2010/main" Requires="a14">
+      <mc:AlternateContent xmlns:mc="http://schemas.openxmlformats.org/markup-compatibility/2006" xmlns:a14="http://schemas.microsoft.com/office/drawing/2010/main">
+        <mc:Choice Requires="a14">
           <p:sp>
             <p:nvSpPr>
               <p:cNvPr id="3" name="내용 개체 틀 2">
@@ -7732,7 +7732,7 @@
             </p:txBody>
           </p:sp>
         </mc:Choice>
-        <mc:Fallback>
+        <mc:Fallback xmlns="">
           <p:sp>
             <p:nvSpPr>
               <p:cNvPr id="3" name="내용 개체 틀 2">
@@ -10020,8 +10020,8 @@
           </a:p>
         </p:txBody>
       </p:sp>
-      <mc:AlternateContent xmlns:mc="http://schemas.openxmlformats.org/markup-compatibility/2006">
-        <mc:Choice xmlns:a14="http://schemas.microsoft.com/office/drawing/2010/main" Requires="a14">
+      <mc:AlternateContent xmlns:mc="http://schemas.openxmlformats.org/markup-compatibility/2006" xmlns:a14="http://schemas.microsoft.com/office/drawing/2010/main">
+        <mc:Choice Requires="a14">
           <p:sp>
             <p:nvSpPr>
               <p:cNvPr id="3" name="내용 개체 틀 2">
@@ -10746,7 +10746,7 @@
             </p:txBody>
           </p:sp>
         </mc:Choice>
-        <mc:Fallback>
+        <mc:Fallback xmlns="">
           <p:sp>
             <p:nvSpPr>
               <p:cNvPr id="3" name="내용 개체 틀 2">
@@ -10880,8 +10880,8 @@
           </a:p>
         </p:txBody>
       </p:sp>
-      <mc:AlternateContent xmlns:mc="http://schemas.openxmlformats.org/markup-compatibility/2006">
-        <mc:Choice xmlns:a14="http://schemas.microsoft.com/office/drawing/2010/main" Requires="a14">
+      <mc:AlternateContent xmlns:mc="http://schemas.openxmlformats.org/markup-compatibility/2006" xmlns:a14="http://schemas.microsoft.com/office/drawing/2010/main">
+        <mc:Choice Requires="a14">
           <p:sp>
             <p:nvSpPr>
               <p:cNvPr id="3" name="내용 개체 틀 2">
@@ -11206,7 +11206,7 @@
             </p:txBody>
           </p:sp>
         </mc:Choice>
-        <mc:Fallback>
+        <mc:Fallback xmlns="">
           <p:sp>
             <p:nvSpPr>
               <p:cNvPr id="3" name="내용 개체 틀 2">
@@ -11326,7 +11326,11 @@
           <a:bodyPr/>
           <a:lstStyle/>
           <a:p>
-            <a:endParaRPr lang="ko-KR" altLang="en-US"/>
+            <a:r>
+              <a:rPr lang="en-US" altLang="ko-KR" dirty="0"/>
+              <a:t>SVP (Shortest Vector Problem)</a:t>
+            </a:r>
+            <a:endParaRPr lang="ko-KR" altLang="en-US" dirty="0"/>
           </a:p>
         </p:txBody>
       </p:sp>

</xml_diff>